<commit_message>
Fix mobile vehicle detail overflow and refresh hosted docs.
Co-authored-by: Cursor <cursoragent@cursor.com>
</commit_message>
<xml_diff>
--- a/Utilisateur/Guide_utilisation_AutoChain_Emma.pptx
+++ b/Utilisateur/Guide_utilisation_AutoChain_Emma.pptx
@@ -20,6 +20,7 @@
     <p:sldId id="268" r:id="rId19"/>
     <p:sldId id="269" r:id="rId20"/>
     <p:sldId id="270" r:id="rId21"/>
+    <p:sldId id="271" r:id="rId22"/>
   </p:sldIdLst>
   <p:sldSz cx="12191695" cy="6858000" type="screen4x3"/>
   <p:notesSz cx="6858000" cy="9144000"/>
@@ -3323,7 +3324,7 @@
                 </a:solidFill>
                 <a:latin typeface="Aptos"/>
               </a:rPr>
-              <a:t>Version 1.0 — Juillet 2026</a:t>
+              <a:t>Version 1.1 — Déploiement validé en juillet 2026</a:t>
             </a:r>
           </a:p>
         </p:txBody>
@@ -6712,7 +6713,7 @@
                 </a:solidFill>
                 <a:latin typeface="Aptos"/>
               </a:rPr>
-              <a:t>BONNES PRATIQUES</a:t>
+              <a:t>PRODUCTION</a:t>
             </a:r>
           </a:p>
         </p:txBody>
@@ -6747,7 +6748,7 @@
                 </a:solidFill>
                 <a:latin typeface="Aptos"/>
               </a:rPr>
-              <a:t>Checklist avant de signer</a:t>
+              <a:t>Application hébergée et services externes</a:t>
             </a:r>
           </a:p>
         </p:txBody>
@@ -6839,7 +6840,7 @@
         <p:spPr>
           <a:xfrm>
             <a:off x="594360" y="1664208"/>
-            <a:ext cx="3398520" cy="4434840"/>
+            <a:ext cx="2491740" cy="4434840"/>
           </a:xfrm>
           <a:prstGeom prst="roundRect">
             <a:avLst/>
@@ -6927,7 +6928,7 @@
         <p:spPr>
           <a:xfrm>
             <a:off x="978408" y="1865376"/>
-            <a:ext cx="2831592" cy="384048"/>
+            <a:ext cx="1924812" cy="384048"/>
           </a:xfrm>
           <a:prstGeom prst="rect">
             <a:avLst/>
@@ -6948,7 +6949,7 @@
                 </a:solidFill>
                 <a:latin typeface="Aptos"/>
               </a:rPr>
-              <a:t>Compte</a:t>
+              <a:t>Application</a:t>
             </a:r>
           </a:p>
         </p:txBody>
@@ -6962,7 +6963,7 @@
         <p:spPr>
           <a:xfrm>
             <a:off x="978408" y="2322576"/>
-            <a:ext cx="2831592" cy="3593591"/>
+            <a:ext cx="1924812" cy="3593591"/>
           </a:xfrm>
           <a:prstGeom prst="rect">
             <a:avLst/>
@@ -6987,7 +6988,7 @@
               </a:defRPr>
             </a:pPr>
             <a:r>
-              <a:t>• Vérifier le nom du compte AutoChain et le rôle affiché.</a:t>
+              <a:t>• https://autochain-emma.onrender.com</a:t>
             </a:r>
           </a:p>
           <a:p>
@@ -7003,7 +7004,7 @@
               </a:defRPr>
             </a:pPr>
             <a:r>
-              <a:t>• Vérifier l’adresse MetaMask sélectionnée.</a:t>
+              <a:t>• Render Free exécute une image Docker publique construite par GitHub Actions.</a:t>
             </a:r>
           </a:p>
         </p:txBody>
@@ -7016,8 +7017,8 @@
         </p:nvSpPr>
         <p:spPr>
           <a:xfrm>
-            <a:off x="4221480" y="1664208"/>
-            <a:ext cx="3398520" cy="4434840"/>
+            <a:off x="3314700" y="1664208"/>
+            <a:ext cx="2491740" cy="4434840"/>
           </a:xfrm>
           <a:prstGeom prst="roundRect">
             <a:avLst/>
@@ -7061,7 +7062,7 @@
         </p:nvSpPr>
         <p:spPr>
           <a:xfrm>
-            <a:off x="4386072" y="1847088"/>
+            <a:off x="3479292" y="1847088"/>
             <a:ext cx="73152" cy="4069079"/>
           </a:xfrm>
           <a:prstGeom prst="roundRect">
@@ -7104,8 +7105,8 @@
         </p:nvSpPr>
         <p:spPr>
           <a:xfrm>
-            <a:off x="4605528" y="1865376"/>
-            <a:ext cx="2831592" cy="384048"/>
+            <a:off x="3698748" y="1865376"/>
+            <a:ext cx="1924812" cy="384048"/>
           </a:xfrm>
           <a:prstGeom prst="rect">
             <a:avLst/>
@@ -7126,7 +7127,7 @@
                 </a:solidFill>
                 <a:latin typeface="Aptos"/>
               </a:rPr>
-              <a:t>Réseau</a:t>
+              <a:t>Données et médias</a:t>
             </a:r>
           </a:p>
         </p:txBody>
@@ -7139,8 +7140,8 @@
         </p:nvSpPr>
         <p:spPr>
           <a:xfrm>
-            <a:off x="4605528" y="2322576"/>
-            <a:ext cx="2831592" cy="3593591"/>
+            <a:off x="3698748" y="2322576"/>
+            <a:ext cx="1924812" cy="3593591"/>
           </a:xfrm>
           <a:prstGeom prst="rect">
             <a:avLst/>
@@ -7165,7 +7166,7 @@
               </a:defRPr>
             </a:pPr>
             <a:r>
-              <a:t>• Contrôler le chain ID et l’adresse du contrat.</a:t>
+              <a:t>• PostgreSQL et stockage S3-compatible sur Supabase.</a:t>
             </a:r>
           </a:p>
           <a:p>
@@ -7181,7 +7182,7 @@
               </a:defRPr>
             </a:pPr>
             <a:r>
-              <a:t>• Lire la fonction demandée dans l’écran de signature.</a:t>
+              <a:t>• Le bucket média public sert avatars, véhicules et logo global.</a:t>
             </a:r>
           </a:p>
         </p:txBody>
@@ -7194,8 +7195,8 @@
         </p:nvSpPr>
         <p:spPr>
           <a:xfrm>
-            <a:off x="7848600" y="1664208"/>
-            <a:ext cx="3398520" cy="4434840"/>
+            <a:off x="6035040" y="1664208"/>
+            <a:ext cx="2491740" cy="4434840"/>
           </a:xfrm>
           <a:prstGeom prst="roundRect">
             <a:avLst/>
@@ -7239,14 +7240,14 @@
         </p:nvSpPr>
         <p:spPr>
           <a:xfrm>
-            <a:off x="8013192" y="1847088"/>
+            <a:off x="6199632" y="1847088"/>
             <a:ext cx="73152" cy="4069079"/>
           </a:xfrm>
           <a:prstGeom prst="roundRect">
             <a:avLst/>
           </a:prstGeom>
           <a:solidFill>
-            <a:srgbClr val="0E7490"/>
+            <a:srgbClr val="EA580C"/>
           </a:solidFill>
           <a:ln>
             <a:noFill/>
@@ -7282,8 +7283,8 @@
         </p:nvSpPr>
         <p:spPr>
           <a:xfrm>
-            <a:off x="8232648" y="1865376"/>
-            <a:ext cx="2831592" cy="384048"/>
+            <a:off x="6419088" y="1865376"/>
+            <a:ext cx="1924812" cy="384048"/>
           </a:xfrm>
           <a:prstGeom prst="rect">
             <a:avLst/>
@@ -7304,7 +7305,7 @@
                 </a:solidFill>
                 <a:latin typeface="Aptos"/>
               </a:rPr>
-              <a:t>Résultat</a:t>
+              <a:t>E-mail et blockchain</a:t>
             </a:r>
           </a:p>
         </p:txBody>
@@ -7317,8 +7318,8 @@
         </p:nvSpPr>
         <p:spPr>
           <a:xfrm>
-            <a:off x="8232648" y="2322576"/>
-            <a:ext cx="2831592" cy="3593591"/>
+            <a:off x="6419088" y="2322576"/>
+            <a:ext cx="1924812" cy="3593591"/>
           </a:xfrm>
           <a:prstGeom prst="rect">
             <a:avLst/>
@@ -7343,7 +7344,7 @@
               </a:defRPr>
             </a:pPr>
             <a:r>
-              <a:t>• Attendre confirmed.</a:t>
+              <a:t>• Brevo envoie MFA et notifications via HTTPS.</a:t>
             </a:r>
           </a:p>
           <a:p>
@@ -7359,14 +7360,192 @@
               </a:defRPr>
             </a:pPr>
             <a:r>
-              <a:t>• Contrôler le hash, le bloc et l’événement dans la timeline.</a:t>
-            </a:r>
-          </a:p>
-        </p:txBody>
-      </p:sp>
-      <p:sp>
-        <p:nvSpPr>
-          <p:cNvPr id="18" name="TextBox 17"/>
+              <a:t>• Sepolia chain ID 11155111 ; chaque signataire paie son gas de test.</a:t>
+            </a:r>
+          </a:p>
+        </p:txBody>
+      </p:sp>
+      <p:sp>
+        <p:nvSpPr>
+          <p:cNvPr id="18" name="Rounded Rectangle 17"/>
+          <p:cNvSpPr/>
+          <p:nvPr/>
+        </p:nvSpPr>
+        <p:spPr>
+          <a:xfrm>
+            <a:off x="8755380" y="1664208"/>
+            <a:ext cx="2491740" cy="4434840"/>
+          </a:xfrm>
+          <a:prstGeom prst="roundRect">
+            <a:avLst/>
+          </a:prstGeom>
+          <a:solidFill>
+            <a:srgbClr val="FFFFFF"/>
+          </a:solidFill>
+          <a:ln>
+            <a:solidFill>
+              <a:srgbClr val="E2E8F0"/>
+            </a:solidFill>
+          </a:ln>
+        </p:spPr>
+        <p:style>
+          <a:lnRef idx="1">
+            <a:schemeClr val="accent1"/>
+          </a:lnRef>
+          <a:fillRef idx="3">
+            <a:schemeClr val="accent1"/>
+          </a:fillRef>
+          <a:effectRef idx="2">
+            <a:schemeClr val="accent1"/>
+          </a:effectRef>
+          <a:fontRef idx="minor">
+            <a:schemeClr val="lt1"/>
+          </a:fontRef>
+        </p:style>
+        <p:txBody>
+          <a:bodyPr rtlCol="0" anchor="ctr"/>
+          <a:lstStyle/>
+          <a:p>
+            <a:pPr algn="ctr"/>
+          </a:p>
+        </p:txBody>
+      </p:sp>
+      <p:sp>
+        <p:nvSpPr>
+          <p:cNvPr id="19" name="Rounded Rectangle 18"/>
+          <p:cNvSpPr/>
+          <p:nvPr/>
+        </p:nvSpPr>
+        <p:spPr>
+          <a:xfrm>
+            <a:off x="8919972" y="1847088"/>
+            <a:ext cx="73152" cy="4069079"/>
+          </a:xfrm>
+          <a:prstGeom prst="roundRect">
+            <a:avLst/>
+          </a:prstGeom>
+          <a:solidFill>
+            <a:srgbClr val="64748B"/>
+          </a:solidFill>
+          <a:ln>
+            <a:noFill/>
+          </a:ln>
+        </p:spPr>
+        <p:style>
+          <a:lnRef idx="1">
+            <a:schemeClr val="accent1"/>
+          </a:lnRef>
+          <a:fillRef idx="3">
+            <a:schemeClr val="accent1"/>
+          </a:fillRef>
+          <a:effectRef idx="2">
+            <a:schemeClr val="accent1"/>
+          </a:effectRef>
+          <a:fontRef idx="minor">
+            <a:schemeClr val="lt1"/>
+          </a:fontRef>
+        </p:style>
+        <p:txBody>
+          <a:bodyPr rtlCol="0" anchor="ctr"/>
+          <a:lstStyle/>
+          <a:p>
+            <a:pPr algn="ctr"/>
+          </a:p>
+        </p:txBody>
+      </p:sp>
+      <p:sp>
+        <p:nvSpPr>
+          <p:cNvPr id="20" name="TextBox 19"/>
+          <p:cNvSpPr txBox="1"/>
+          <p:nvPr/>
+        </p:nvSpPr>
+        <p:spPr>
+          <a:xfrm>
+            <a:off x="9139428" y="1865376"/>
+            <a:ext cx="1924812" cy="384048"/>
+          </a:xfrm>
+          <a:prstGeom prst="rect">
+            <a:avLst/>
+          </a:prstGeom>
+          <a:noFill/>
+        </p:spPr>
+        <p:txBody>
+          <a:bodyPr wrap="none" lIns="45720" rIns="45720" anchor="ctr">
+            <a:spAutoFit/>
+          </a:bodyPr>
+          <a:lstStyle/>
+          <a:p>
+            <a:pPr algn="l"/>
+            <a:r>
+              <a:rPr sz="1500" b="1">
+                <a:solidFill>
+                  <a:srgbClr val="0F172A"/>
+                </a:solidFill>
+                <a:latin typeface="Aptos"/>
+              </a:rPr>
+              <a:t>Limites gratuites</a:t>
+            </a:r>
+          </a:p>
+        </p:txBody>
+      </p:sp>
+      <p:sp>
+        <p:nvSpPr>
+          <p:cNvPr id="21" name="TextBox 20"/>
+          <p:cNvSpPr txBox="1"/>
+          <p:nvPr/>
+        </p:nvSpPr>
+        <p:spPr>
+          <a:xfrm>
+            <a:off x="9139428" y="2322576"/>
+            <a:ext cx="1924812" cy="3593591"/>
+          </a:xfrm>
+          <a:prstGeom prst="rect">
+            <a:avLst/>
+          </a:prstGeom>
+          <a:noFill/>
+        </p:spPr>
+        <p:txBody>
+          <a:bodyPr wrap="square" lIns="0" rIns="0" tIns="0" bIns="0">
+            <a:spAutoFit/>
+          </a:bodyPr>
+          <a:lstStyle/>
+          <a:p>
+            <a:pPr>
+              <a:spcAft>
+                <a:spcPts val="700"/>
+              </a:spcAft>
+              <a:defRPr sz="1200">
+                <a:solidFill>
+                  <a:srgbClr val="334155"/>
+                </a:solidFill>
+                <a:latin typeface="Aptos"/>
+              </a:defRPr>
+            </a:pPr>
+            <a:r>
+              <a:t>• Render peut mettre le service en veille.</a:t>
+            </a:r>
+          </a:p>
+          <a:p>
+            <a:pPr>
+              <a:spcAft>
+                <a:spcPts val="700"/>
+              </a:spcAft>
+              <a:defRPr sz="1200">
+                <a:solidFill>
+                  <a:srgbClr val="334155"/>
+                </a:solidFill>
+                <a:latin typeface="Aptos"/>
+              </a:defRPr>
+            </a:pPr>
+            <a:r>
+              <a:t>• Queue synchrone et scheduler actif uniquement lorsque le service est éveillé.</a:t>
+            </a:r>
+          </a:p>
+        </p:txBody>
+      </p:sp>
+      <p:sp>
+        <p:nvSpPr>
+          <p:cNvPr id="22" name="TextBox 21"/>
           <p:cNvSpPr txBox="1"/>
           <p:nvPr/>
         </p:nvSpPr>
@@ -7408,6 +7587,749 @@
 </file>
 
 <file path=ppt/slides/slide15.xml><?xml version="1.0" encoding="utf-8"?>
+<p:sld xmlns:a="http://schemas.openxmlformats.org/drawingml/2006/main" xmlns:p="http://schemas.openxmlformats.org/presentationml/2006/main" xmlns:r="http://schemas.openxmlformats.org/officeDocument/2006/relationships">
+  <p:cSld>
+    <p:bg>
+      <p:bgPr>
+        <a:solidFill>
+          <a:srgbClr val="F1F5F9"/>
+        </a:solidFill>
+        <a:effectLst/>
+      </p:bgPr>
+    </p:bg>
+    <p:spTree>
+      <p:nvGrpSpPr>
+        <p:cNvPr id="1" name=""/>
+        <p:cNvGrpSpPr/>
+        <p:nvPr/>
+      </p:nvGrpSpPr>
+      <p:grpSpPr/>
+      <p:sp>
+        <p:nvSpPr>
+          <p:cNvPr id="2" name="TextBox 1"/>
+          <p:cNvSpPr txBox="1"/>
+          <p:nvPr/>
+        </p:nvSpPr>
+        <p:spPr>
+          <a:xfrm>
+            <a:off x="594360" y="320040"/>
+            <a:ext cx="8961120" cy="320040"/>
+          </a:xfrm>
+          <a:prstGeom prst="rect">
+            <a:avLst/>
+          </a:prstGeom>
+          <a:noFill/>
+        </p:spPr>
+        <p:txBody>
+          <a:bodyPr wrap="none" lIns="45720" rIns="45720" anchor="ctr">
+            <a:spAutoFit/>
+          </a:bodyPr>
+          <a:lstStyle/>
+          <a:p>
+            <a:pPr algn="l"/>
+            <a:r>
+              <a:rPr sz="1000" b="1">
+                <a:solidFill>
+                  <a:srgbClr val="818CF8"/>
+                </a:solidFill>
+                <a:latin typeface="Aptos"/>
+              </a:rPr>
+              <a:t>BONNES PRATIQUES</a:t>
+            </a:r>
+          </a:p>
+        </p:txBody>
+      </p:sp>
+      <p:sp>
+        <p:nvSpPr>
+          <p:cNvPr id="3" name="TextBox 2"/>
+          <p:cNvSpPr txBox="1"/>
+          <p:nvPr/>
+        </p:nvSpPr>
+        <p:spPr>
+          <a:xfrm>
+            <a:off x="594360" y="658368"/>
+            <a:ext cx="10789920" cy="640080"/>
+          </a:xfrm>
+          <a:prstGeom prst="rect">
+            <a:avLst/>
+          </a:prstGeom>
+          <a:noFill/>
+        </p:spPr>
+        <p:txBody>
+          <a:bodyPr wrap="none" lIns="45720" rIns="45720" anchor="ctr">
+            <a:spAutoFit/>
+          </a:bodyPr>
+          <a:lstStyle/>
+          <a:p>
+            <a:pPr algn="l"/>
+            <a:r>
+              <a:rPr sz="2800" b="1">
+                <a:solidFill>
+                  <a:srgbClr val="0F172A"/>
+                </a:solidFill>
+                <a:latin typeface="Aptos"/>
+              </a:rPr>
+              <a:t>Checklist avant de signer</a:t>
+            </a:r>
+          </a:p>
+        </p:txBody>
+      </p:sp>
+      <p:sp>
+        <p:nvSpPr>
+          <p:cNvPr id="4" name="TextBox 3"/>
+          <p:cNvSpPr txBox="1"/>
+          <p:nvPr/>
+        </p:nvSpPr>
+        <p:spPr>
+          <a:xfrm>
+            <a:off x="11155680" y="347472"/>
+            <a:ext cx="411480" cy="320040"/>
+          </a:xfrm>
+          <a:prstGeom prst="rect">
+            <a:avLst/>
+          </a:prstGeom>
+          <a:noFill/>
+        </p:spPr>
+        <p:txBody>
+          <a:bodyPr wrap="none" lIns="45720" rIns="45720" anchor="ctr">
+            <a:spAutoFit/>
+          </a:bodyPr>
+          <a:lstStyle/>
+          <a:p>
+            <a:pPr algn="r"/>
+            <a:r>
+              <a:rPr sz="1100" b="1">
+                <a:solidFill>
+                  <a:srgbClr val="4F46E5"/>
+                </a:solidFill>
+                <a:latin typeface="Aptos"/>
+              </a:rPr>
+              <a:t>15</a:t>
+            </a:r>
+          </a:p>
+        </p:txBody>
+      </p:sp>
+      <p:sp>
+        <p:nvSpPr>
+          <p:cNvPr id="5" name="Rectangle 4"/>
+          <p:cNvSpPr/>
+          <p:nvPr/>
+        </p:nvSpPr>
+        <p:spPr>
+          <a:xfrm>
+            <a:off x="594360" y="1353312"/>
+            <a:ext cx="10972800" cy="32004"/>
+          </a:xfrm>
+          <a:prstGeom prst="rect">
+            <a:avLst/>
+          </a:prstGeom>
+          <a:solidFill>
+            <a:srgbClr val="E2E8F0"/>
+          </a:solidFill>
+          <a:ln>
+            <a:noFill/>
+          </a:ln>
+        </p:spPr>
+        <p:style>
+          <a:lnRef idx="1">
+            <a:schemeClr val="accent1"/>
+          </a:lnRef>
+          <a:fillRef idx="3">
+            <a:schemeClr val="accent1"/>
+          </a:fillRef>
+          <a:effectRef idx="2">
+            <a:schemeClr val="accent1"/>
+          </a:effectRef>
+          <a:fontRef idx="minor">
+            <a:schemeClr val="lt1"/>
+          </a:fontRef>
+        </p:style>
+        <p:txBody>
+          <a:bodyPr rtlCol="0" anchor="ctr"/>
+          <a:lstStyle/>
+          <a:p>
+            <a:pPr algn="ctr"/>
+          </a:p>
+        </p:txBody>
+      </p:sp>
+      <p:sp>
+        <p:nvSpPr>
+          <p:cNvPr id="6" name="Rounded Rectangle 5"/>
+          <p:cNvSpPr/>
+          <p:nvPr/>
+        </p:nvSpPr>
+        <p:spPr>
+          <a:xfrm>
+            <a:off x="594360" y="1664208"/>
+            <a:ext cx="3398520" cy="4434840"/>
+          </a:xfrm>
+          <a:prstGeom prst="roundRect">
+            <a:avLst/>
+          </a:prstGeom>
+          <a:solidFill>
+            <a:srgbClr val="FFFFFF"/>
+          </a:solidFill>
+          <a:ln>
+            <a:solidFill>
+              <a:srgbClr val="E2E8F0"/>
+            </a:solidFill>
+          </a:ln>
+        </p:spPr>
+        <p:style>
+          <a:lnRef idx="1">
+            <a:schemeClr val="accent1"/>
+          </a:lnRef>
+          <a:fillRef idx="3">
+            <a:schemeClr val="accent1"/>
+          </a:fillRef>
+          <a:effectRef idx="2">
+            <a:schemeClr val="accent1"/>
+          </a:effectRef>
+          <a:fontRef idx="minor">
+            <a:schemeClr val="lt1"/>
+          </a:fontRef>
+        </p:style>
+        <p:txBody>
+          <a:bodyPr rtlCol="0" anchor="ctr"/>
+          <a:lstStyle/>
+          <a:p>
+            <a:pPr algn="ctr"/>
+          </a:p>
+        </p:txBody>
+      </p:sp>
+      <p:sp>
+        <p:nvSpPr>
+          <p:cNvPr id="7" name="Rounded Rectangle 6"/>
+          <p:cNvSpPr/>
+          <p:nvPr/>
+        </p:nvSpPr>
+        <p:spPr>
+          <a:xfrm>
+            <a:off x="758952" y="1847088"/>
+            <a:ext cx="73152" cy="4069079"/>
+          </a:xfrm>
+          <a:prstGeom prst="roundRect">
+            <a:avLst/>
+          </a:prstGeom>
+          <a:solidFill>
+            <a:srgbClr val="4F46E5"/>
+          </a:solidFill>
+          <a:ln>
+            <a:noFill/>
+          </a:ln>
+        </p:spPr>
+        <p:style>
+          <a:lnRef idx="1">
+            <a:schemeClr val="accent1"/>
+          </a:lnRef>
+          <a:fillRef idx="3">
+            <a:schemeClr val="accent1"/>
+          </a:fillRef>
+          <a:effectRef idx="2">
+            <a:schemeClr val="accent1"/>
+          </a:effectRef>
+          <a:fontRef idx="minor">
+            <a:schemeClr val="lt1"/>
+          </a:fontRef>
+        </p:style>
+        <p:txBody>
+          <a:bodyPr rtlCol="0" anchor="ctr"/>
+          <a:lstStyle/>
+          <a:p>
+            <a:pPr algn="ctr"/>
+          </a:p>
+        </p:txBody>
+      </p:sp>
+      <p:sp>
+        <p:nvSpPr>
+          <p:cNvPr id="8" name="TextBox 7"/>
+          <p:cNvSpPr txBox="1"/>
+          <p:nvPr/>
+        </p:nvSpPr>
+        <p:spPr>
+          <a:xfrm>
+            <a:off x="978408" y="1865376"/>
+            <a:ext cx="2831592" cy="384048"/>
+          </a:xfrm>
+          <a:prstGeom prst="rect">
+            <a:avLst/>
+          </a:prstGeom>
+          <a:noFill/>
+        </p:spPr>
+        <p:txBody>
+          <a:bodyPr wrap="none" lIns="45720" rIns="45720" anchor="ctr">
+            <a:spAutoFit/>
+          </a:bodyPr>
+          <a:lstStyle/>
+          <a:p>
+            <a:pPr algn="l"/>
+            <a:r>
+              <a:rPr sz="1500" b="1">
+                <a:solidFill>
+                  <a:srgbClr val="0F172A"/>
+                </a:solidFill>
+                <a:latin typeface="Aptos"/>
+              </a:rPr>
+              <a:t>Compte</a:t>
+            </a:r>
+          </a:p>
+        </p:txBody>
+      </p:sp>
+      <p:sp>
+        <p:nvSpPr>
+          <p:cNvPr id="9" name="TextBox 8"/>
+          <p:cNvSpPr txBox="1"/>
+          <p:nvPr/>
+        </p:nvSpPr>
+        <p:spPr>
+          <a:xfrm>
+            <a:off x="978408" y="2322576"/>
+            <a:ext cx="2831592" cy="3593591"/>
+          </a:xfrm>
+          <a:prstGeom prst="rect">
+            <a:avLst/>
+          </a:prstGeom>
+          <a:noFill/>
+        </p:spPr>
+        <p:txBody>
+          <a:bodyPr wrap="square" lIns="0" rIns="0" tIns="0" bIns="0">
+            <a:spAutoFit/>
+          </a:bodyPr>
+          <a:lstStyle/>
+          <a:p>
+            <a:pPr>
+              <a:spcAft>
+                <a:spcPts val="700"/>
+              </a:spcAft>
+              <a:defRPr sz="1200">
+                <a:solidFill>
+                  <a:srgbClr val="334155"/>
+                </a:solidFill>
+                <a:latin typeface="Aptos"/>
+              </a:defRPr>
+            </a:pPr>
+            <a:r>
+              <a:t>• Vérifier le nom du compte AutoChain et le rôle affiché.</a:t>
+            </a:r>
+          </a:p>
+          <a:p>
+            <a:pPr>
+              <a:spcAft>
+                <a:spcPts val="700"/>
+              </a:spcAft>
+              <a:defRPr sz="1200">
+                <a:solidFill>
+                  <a:srgbClr val="334155"/>
+                </a:solidFill>
+                <a:latin typeface="Aptos"/>
+              </a:defRPr>
+            </a:pPr>
+            <a:r>
+              <a:t>• Vérifier l’adresse MetaMask sélectionnée.</a:t>
+            </a:r>
+          </a:p>
+        </p:txBody>
+      </p:sp>
+      <p:sp>
+        <p:nvSpPr>
+          <p:cNvPr id="10" name="Rounded Rectangle 9"/>
+          <p:cNvSpPr/>
+          <p:nvPr/>
+        </p:nvSpPr>
+        <p:spPr>
+          <a:xfrm>
+            <a:off x="4221480" y="1664208"/>
+            <a:ext cx="3398520" cy="4434840"/>
+          </a:xfrm>
+          <a:prstGeom prst="roundRect">
+            <a:avLst/>
+          </a:prstGeom>
+          <a:solidFill>
+            <a:srgbClr val="FFFFFF"/>
+          </a:solidFill>
+          <a:ln>
+            <a:solidFill>
+              <a:srgbClr val="E2E8F0"/>
+            </a:solidFill>
+          </a:ln>
+        </p:spPr>
+        <p:style>
+          <a:lnRef idx="1">
+            <a:schemeClr val="accent1"/>
+          </a:lnRef>
+          <a:fillRef idx="3">
+            <a:schemeClr val="accent1"/>
+          </a:fillRef>
+          <a:effectRef idx="2">
+            <a:schemeClr val="accent1"/>
+          </a:effectRef>
+          <a:fontRef idx="minor">
+            <a:schemeClr val="lt1"/>
+          </a:fontRef>
+        </p:style>
+        <p:txBody>
+          <a:bodyPr rtlCol="0" anchor="ctr"/>
+          <a:lstStyle/>
+          <a:p>
+            <a:pPr algn="ctr"/>
+          </a:p>
+        </p:txBody>
+      </p:sp>
+      <p:sp>
+        <p:nvSpPr>
+          <p:cNvPr id="11" name="Rounded Rectangle 10"/>
+          <p:cNvSpPr/>
+          <p:nvPr/>
+        </p:nvSpPr>
+        <p:spPr>
+          <a:xfrm>
+            <a:off x="4386072" y="1847088"/>
+            <a:ext cx="73152" cy="4069079"/>
+          </a:xfrm>
+          <a:prstGeom prst="roundRect">
+            <a:avLst/>
+          </a:prstGeom>
+          <a:solidFill>
+            <a:srgbClr val="059669"/>
+          </a:solidFill>
+          <a:ln>
+            <a:noFill/>
+          </a:ln>
+        </p:spPr>
+        <p:style>
+          <a:lnRef idx="1">
+            <a:schemeClr val="accent1"/>
+          </a:lnRef>
+          <a:fillRef idx="3">
+            <a:schemeClr val="accent1"/>
+          </a:fillRef>
+          <a:effectRef idx="2">
+            <a:schemeClr val="accent1"/>
+          </a:effectRef>
+          <a:fontRef idx="minor">
+            <a:schemeClr val="lt1"/>
+          </a:fontRef>
+        </p:style>
+        <p:txBody>
+          <a:bodyPr rtlCol="0" anchor="ctr"/>
+          <a:lstStyle/>
+          <a:p>
+            <a:pPr algn="ctr"/>
+          </a:p>
+        </p:txBody>
+      </p:sp>
+      <p:sp>
+        <p:nvSpPr>
+          <p:cNvPr id="12" name="TextBox 11"/>
+          <p:cNvSpPr txBox="1"/>
+          <p:nvPr/>
+        </p:nvSpPr>
+        <p:spPr>
+          <a:xfrm>
+            <a:off x="4605528" y="1865376"/>
+            <a:ext cx="2831592" cy="384048"/>
+          </a:xfrm>
+          <a:prstGeom prst="rect">
+            <a:avLst/>
+          </a:prstGeom>
+          <a:noFill/>
+        </p:spPr>
+        <p:txBody>
+          <a:bodyPr wrap="none" lIns="45720" rIns="45720" anchor="ctr">
+            <a:spAutoFit/>
+          </a:bodyPr>
+          <a:lstStyle/>
+          <a:p>
+            <a:pPr algn="l"/>
+            <a:r>
+              <a:rPr sz="1500" b="1">
+                <a:solidFill>
+                  <a:srgbClr val="0F172A"/>
+                </a:solidFill>
+                <a:latin typeface="Aptos"/>
+              </a:rPr>
+              <a:t>Réseau</a:t>
+            </a:r>
+          </a:p>
+        </p:txBody>
+      </p:sp>
+      <p:sp>
+        <p:nvSpPr>
+          <p:cNvPr id="13" name="TextBox 12"/>
+          <p:cNvSpPr txBox="1"/>
+          <p:nvPr/>
+        </p:nvSpPr>
+        <p:spPr>
+          <a:xfrm>
+            <a:off x="4605528" y="2322576"/>
+            <a:ext cx="2831592" cy="3593591"/>
+          </a:xfrm>
+          <a:prstGeom prst="rect">
+            <a:avLst/>
+          </a:prstGeom>
+          <a:noFill/>
+        </p:spPr>
+        <p:txBody>
+          <a:bodyPr wrap="square" lIns="0" rIns="0" tIns="0" bIns="0">
+            <a:spAutoFit/>
+          </a:bodyPr>
+          <a:lstStyle/>
+          <a:p>
+            <a:pPr>
+              <a:spcAft>
+                <a:spcPts val="700"/>
+              </a:spcAft>
+              <a:defRPr sz="1200">
+                <a:solidFill>
+                  <a:srgbClr val="334155"/>
+                </a:solidFill>
+                <a:latin typeface="Aptos"/>
+              </a:defRPr>
+            </a:pPr>
+            <a:r>
+              <a:t>• Contrôler le chain ID et l’adresse du contrat.</a:t>
+            </a:r>
+          </a:p>
+          <a:p>
+            <a:pPr>
+              <a:spcAft>
+                <a:spcPts val="700"/>
+              </a:spcAft>
+              <a:defRPr sz="1200">
+                <a:solidFill>
+                  <a:srgbClr val="334155"/>
+                </a:solidFill>
+                <a:latin typeface="Aptos"/>
+              </a:defRPr>
+            </a:pPr>
+            <a:r>
+              <a:t>• Lire la fonction demandée dans l’écran de signature.</a:t>
+            </a:r>
+          </a:p>
+        </p:txBody>
+      </p:sp>
+      <p:sp>
+        <p:nvSpPr>
+          <p:cNvPr id="14" name="Rounded Rectangle 13"/>
+          <p:cNvSpPr/>
+          <p:nvPr/>
+        </p:nvSpPr>
+        <p:spPr>
+          <a:xfrm>
+            <a:off x="7848600" y="1664208"/>
+            <a:ext cx="3398520" cy="4434840"/>
+          </a:xfrm>
+          <a:prstGeom prst="roundRect">
+            <a:avLst/>
+          </a:prstGeom>
+          <a:solidFill>
+            <a:srgbClr val="FFFFFF"/>
+          </a:solidFill>
+          <a:ln>
+            <a:solidFill>
+              <a:srgbClr val="E2E8F0"/>
+            </a:solidFill>
+          </a:ln>
+        </p:spPr>
+        <p:style>
+          <a:lnRef idx="1">
+            <a:schemeClr val="accent1"/>
+          </a:lnRef>
+          <a:fillRef idx="3">
+            <a:schemeClr val="accent1"/>
+          </a:fillRef>
+          <a:effectRef idx="2">
+            <a:schemeClr val="accent1"/>
+          </a:effectRef>
+          <a:fontRef idx="minor">
+            <a:schemeClr val="lt1"/>
+          </a:fontRef>
+        </p:style>
+        <p:txBody>
+          <a:bodyPr rtlCol="0" anchor="ctr"/>
+          <a:lstStyle/>
+          <a:p>
+            <a:pPr algn="ctr"/>
+          </a:p>
+        </p:txBody>
+      </p:sp>
+      <p:sp>
+        <p:nvSpPr>
+          <p:cNvPr id="15" name="Rounded Rectangle 14"/>
+          <p:cNvSpPr/>
+          <p:nvPr/>
+        </p:nvSpPr>
+        <p:spPr>
+          <a:xfrm>
+            <a:off x="8013192" y="1847088"/>
+            <a:ext cx="73152" cy="4069079"/>
+          </a:xfrm>
+          <a:prstGeom prst="roundRect">
+            <a:avLst/>
+          </a:prstGeom>
+          <a:solidFill>
+            <a:srgbClr val="0E7490"/>
+          </a:solidFill>
+          <a:ln>
+            <a:noFill/>
+          </a:ln>
+        </p:spPr>
+        <p:style>
+          <a:lnRef idx="1">
+            <a:schemeClr val="accent1"/>
+          </a:lnRef>
+          <a:fillRef idx="3">
+            <a:schemeClr val="accent1"/>
+          </a:fillRef>
+          <a:effectRef idx="2">
+            <a:schemeClr val="accent1"/>
+          </a:effectRef>
+          <a:fontRef idx="minor">
+            <a:schemeClr val="lt1"/>
+          </a:fontRef>
+        </p:style>
+        <p:txBody>
+          <a:bodyPr rtlCol="0" anchor="ctr"/>
+          <a:lstStyle/>
+          <a:p>
+            <a:pPr algn="ctr"/>
+          </a:p>
+        </p:txBody>
+      </p:sp>
+      <p:sp>
+        <p:nvSpPr>
+          <p:cNvPr id="16" name="TextBox 15"/>
+          <p:cNvSpPr txBox="1"/>
+          <p:nvPr/>
+        </p:nvSpPr>
+        <p:spPr>
+          <a:xfrm>
+            <a:off x="8232648" y="1865376"/>
+            <a:ext cx="2831592" cy="384048"/>
+          </a:xfrm>
+          <a:prstGeom prst="rect">
+            <a:avLst/>
+          </a:prstGeom>
+          <a:noFill/>
+        </p:spPr>
+        <p:txBody>
+          <a:bodyPr wrap="none" lIns="45720" rIns="45720" anchor="ctr">
+            <a:spAutoFit/>
+          </a:bodyPr>
+          <a:lstStyle/>
+          <a:p>
+            <a:pPr algn="l"/>
+            <a:r>
+              <a:rPr sz="1500" b="1">
+                <a:solidFill>
+                  <a:srgbClr val="0F172A"/>
+                </a:solidFill>
+                <a:latin typeface="Aptos"/>
+              </a:rPr>
+              <a:t>Résultat</a:t>
+            </a:r>
+          </a:p>
+        </p:txBody>
+      </p:sp>
+      <p:sp>
+        <p:nvSpPr>
+          <p:cNvPr id="17" name="TextBox 16"/>
+          <p:cNvSpPr txBox="1"/>
+          <p:nvPr/>
+        </p:nvSpPr>
+        <p:spPr>
+          <a:xfrm>
+            <a:off x="8232648" y="2322576"/>
+            <a:ext cx="2831592" cy="3593591"/>
+          </a:xfrm>
+          <a:prstGeom prst="rect">
+            <a:avLst/>
+          </a:prstGeom>
+          <a:noFill/>
+        </p:spPr>
+        <p:txBody>
+          <a:bodyPr wrap="square" lIns="0" rIns="0" tIns="0" bIns="0">
+            <a:spAutoFit/>
+          </a:bodyPr>
+          <a:lstStyle/>
+          <a:p>
+            <a:pPr>
+              <a:spcAft>
+                <a:spcPts val="700"/>
+              </a:spcAft>
+              <a:defRPr sz="1200">
+                <a:solidFill>
+                  <a:srgbClr val="334155"/>
+                </a:solidFill>
+                <a:latin typeface="Aptos"/>
+              </a:defRPr>
+            </a:pPr>
+            <a:r>
+              <a:t>• Attendre confirmed.</a:t>
+            </a:r>
+          </a:p>
+          <a:p>
+            <a:pPr>
+              <a:spcAft>
+                <a:spcPts val="700"/>
+              </a:spcAft>
+              <a:defRPr sz="1200">
+                <a:solidFill>
+                  <a:srgbClr val="334155"/>
+                </a:solidFill>
+                <a:latin typeface="Aptos"/>
+              </a:defRPr>
+            </a:pPr>
+            <a:r>
+              <a:t>• Contrôler le hash, le bloc et l’événement dans la timeline.</a:t>
+            </a:r>
+          </a:p>
+        </p:txBody>
+      </p:sp>
+      <p:sp>
+        <p:nvSpPr>
+          <p:cNvPr id="18" name="TextBox 17"/>
+          <p:cNvSpPr txBox="1"/>
+          <p:nvPr/>
+        </p:nvSpPr>
+        <p:spPr>
+          <a:xfrm>
+            <a:off x="594360" y="6473952"/>
+            <a:ext cx="10972800" cy="201168"/>
+          </a:xfrm>
+          <a:prstGeom prst="rect">
+            <a:avLst/>
+          </a:prstGeom>
+          <a:noFill/>
+        </p:spPr>
+        <p:txBody>
+          <a:bodyPr wrap="none" lIns="45720" rIns="45720" anchor="ctr">
+            <a:spAutoFit/>
+          </a:bodyPr>
+          <a:lstStyle/>
+          <a:p>
+            <a:pPr algn="l"/>
+            <a:r>
+              <a:rPr sz="800" b="0">
+                <a:solidFill>
+                  <a:srgbClr val="94A3B8"/>
+                </a:solidFill>
+                <a:latin typeface="Aptos"/>
+              </a:rPr>
+              <a:t>AutoChain Emma+  |  Guide utilisateur  |  Juillet 2026</a:t>
+            </a:r>
+          </a:p>
+        </p:txBody>
+      </p:sp>
+    </p:spTree>
+  </p:cSld>
+  <p:clrMapOvr>
+    <a:masterClrMapping/>
+  </p:clrMapOvr>
+</p:sld>
+</file>
+
+<file path=ppt/slides/slide16.xml><?xml version="1.0" encoding="utf-8"?>
 <p:sld xmlns:a="http://schemas.openxmlformats.org/drawingml/2006/main" xmlns:p="http://schemas.openxmlformats.org/presentationml/2006/main" xmlns:r="http://schemas.openxmlformats.org/officeDocument/2006/relationships">
   <p:cSld>
     <p:bg>
@@ -8690,7 +9612,7 @@
               </a:defRPr>
             </a:pPr>
             <a:r>
-              <a:t>• Saisir le code MFA lorsque la protection est activée.</a:t>
+              <a:t>• Saisir le code MFA reçu par e-mail : il est obligatoire pour tous.</a:t>
             </a:r>
           </a:p>
         </p:txBody>

</xml_diff>